<commit_message>
minor updates to text
</commit_message>
<xml_diff>
--- a/slides/FISABIO_workshop_v1.pptx
+++ b/slides/FISABIO_workshop_v1.pptx
@@ -5,20 +5,21 @@
     <p:sldMasterId id="2147483648" r:id="rId1"/>
   </p:sldMasterIdLst>
   <p:notesMasterIdLst>
-    <p:notesMasterId r:id="rId13"/>
+    <p:notesMasterId r:id="rId14"/>
   </p:notesMasterIdLst>
   <p:sldIdLst>
     <p:sldId id="287" r:id="rId2"/>
     <p:sldId id="321" r:id="rId3"/>
-    <p:sldId id="323" r:id="rId4"/>
-    <p:sldId id="331" r:id="rId5"/>
-    <p:sldId id="324" r:id="rId6"/>
-    <p:sldId id="325" r:id="rId7"/>
-    <p:sldId id="326" r:id="rId8"/>
-    <p:sldId id="327" r:id="rId9"/>
-    <p:sldId id="328" r:id="rId10"/>
-    <p:sldId id="329" r:id="rId11"/>
-    <p:sldId id="330" r:id="rId12"/>
+    <p:sldId id="332" r:id="rId4"/>
+    <p:sldId id="323" r:id="rId5"/>
+    <p:sldId id="331" r:id="rId6"/>
+    <p:sldId id="324" r:id="rId7"/>
+    <p:sldId id="325" r:id="rId8"/>
+    <p:sldId id="326" r:id="rId9"/>
+    <p:sldId id="327" r:id="rId10"/>
+    <p:sldId id="328" r:id="rId11"/>
+    <p:sldId id="329" r:id="rId12"/>
+    <p:sldId id="330" r:id="rId13"/>
   </p:sldIdLst>
   <p:sldSz cx="12192000" cy="6858000"/>
   <p:notesSz cx="6858000" cy="9144000"/>
@@ -128,7 +129,7 @@
 <file path=ppt/revisionInfo.xml><?xml version="1.0" encoding="utf-8"?>
 <p1510:revInfo xmlns:a="http://schemas.openxmlformats.org/drawingml/2006/main" xmlns:r="http://schemas.openxmlformats.org/officeDocument/2006/relationships" xmlns:p1510="http://schemas.microsoft.com/office/powerpoint/2015/10/main">
   <p1510:revLst>
-    <p1510:client id="{B87E26C0-E1A9-524D-BD8D-9134100C2927}" v="6" dt="2026-06-30T09:14:46.973"/>
+    <p1510:client id="{B87E26C0-E1A9-524D-BD8D-9134100C2927}" v="2" dt="2026-07-06T02:49:25.927"/>
   </p1510:revLst>
 </p1510:revInfo>
 </file>
@@ -137,11 +138,26 @@
 <pc:chgInfo xmlns:a="http://schemas.openxmlformats.org/drawingml/2006/main" xmlns:r="http://schemas.openxmlformats.org/officeDocument/2006/relationships" xmlns:ac="http://schemas.microsoft.com/office/drawing/2013/main/command" xmlns:pc="http://schemas.microsoft.com/office/powerpoint/2013/main/command">
   <pc:docChgLst>
     <pc:chgData name="Kshitij Tandon" userId="15634347-acbf-4539-84f7-139d21f51226" providerId="ADAL" clId="{0A25E2B8-B0B5-54DF-BADD-6F926CE8A598}"/>
-    <pc:docChg chg="undo custSel modSld">
-      <pc:chgData name="Kshitij Tandon" userId="15634347-acbf-4539-84f7-139d21f51226" providerId="ADAL" clId="{0A25E2B8-B0B5-54DF-BADD-6F926CE8A598}" dt="2026-07-01T02:06:17.840" v="59" actId="478"/>
+    <pc:docChg chg="undo custSel addSld modSld">
+      <pc:chgData name="Kshitij Tandon" userId="15634347-acbf-4539-84f7-139d21f51226" providerId="ADAL" clId="{0A25E2B8-B0B5-54DF-BADD-6F926CE8A598}" dt="2026-07-06T02:49:39.893" v="205" actId="478"/>
       <pc:docMkLst>
         <pc:docMk/>
       </pc:docMkLst>
+      <pc:sldChg chg="modSp mod">
+        <pc:chgData name="Kshitij Tandon" userId="15634347-acbf-4539-84f7-139d21f51226" providerId="ADAL" clId="{0A25E2B8-B0B5-54DF-BADD-6F926CE8A598}" dt="2026-07-06T02:49:29.551" v="203" actId="113"/>
+        <pc:sldMkLst>
+          <pc:docMk/>
+          <pc:sldMk cId="2962316723" sldId="321"/>
+        </pc:sldMkLst>
+        <pc:spChg chg="mod">
+          <ac:chgData name="Kshitij Tandon" userId="15634347-acbf-4539-84f7-139d21f51226" providerId="ADAL" clId="{0A25E2B8-B0B5-54DF-BADD-6F926CE8A598}" dt="2026-07-06T02:49:29.551" v="203" actId="113"/>
+          <ac:spMkLst>
+            <pc:docMk/>
+            <pc:sldMk cId="2962316723" sldId="321"/>
+            <ac:spMk id="5" creationId="{F5208298-E042-9809-0C3B-26B64D9E31E7}"/>
+          </ac:spMkLst>
+        </pc:spChg>
+      </pc:sldChg>
       <pc:sldChg chg="addSp delSp modSp mod">
         <pc:chgData name="Kshitij Tandon" userId="15634347-acbf-4539-84f7-139d21f51226" providerId="ADAL" clId="{0A25E2B8-B0B5-54DF-BADD-6F926CE8A598}" dt="2026-06-30T03:52:01.847" v="33" actId="207"/>
         <pc:sldMkLst>
@@ -156,14 +172,6 @@
             <ac:spMk id="8" creationId="{28076344-6ADE-FF7C-4B7E-C05E456008AF}"/>
           </ac:spMkLst>
         </pc:spChg>
-        <pc:picChg chg="add del mod">
-          <ac:chgData name="Kshitij Tandon" userId="15634347-acbf-4539-84f7-139d21f51226" providerId="ADAL" clId="{0A25E2B8-B0B5-54DF-BADD-6F926CE8A598}" dt="2026-06-30T03:51:45.369" v="2" actId="21"/>
-          <ac:picMkLst>
-            <pc:docMk/>
-            <pc:sldMk cId="2400250369" sldId="324"/>
-            <ac:picMk id="2" creationId="{028BCF67-6B34-9CE1-3653-FAB71F283BC3}"/>
-          </ac:picMkLst>
-        </pc:picChg>
       </pc:sldChg>
       <pc:sldChg chg="addSp modSp mod">
         <pc:chgData name="Kshitij Tandon" userId="15634347-acbf-4539-84f7-139d21f51226" providerId="ADAL" clId="{0A25E2B8-B0B5-54DF-BADD-6F926CE8A598}" dt="2026-06-30T03:51:54.029" v="31" actId="20577"/>
@@ -194,46 +202,37 @@
           <pc:docMk/>
           <pc:sldMk cId="3138601588" sldId="326"/>
         </pc:sldMkLst>
-        <pc:picChg chg="add del mod">
-          <ac:chgData name="Kshitij Tandon" userId="15634347-acbf-4539-84f7-139d21f51226" providerId="ADAL" clId="{0A25E2B8-B0B5-54DF-BADD-6F926CE8A598}" dt="2026-06-30T09:13:41.577" v="41" actId="478"/>
-          <ac:picMkLst>
+      </pc:sldChg>
+      <pc:sldChg chg="delSp modSp new mod">
+        <pc:chgData name="Kshitij Tandon" userId="15634347-acbf-4539-84f7-139d21f51226" providerId="ADAL" clId="{0A25E2B8-B0B5-54DF-BADD-6F926CE8A598}" dt="2026-07-06T02:49:39.893" v="205" actId="478"/>
+        <pc:sldMkLst>
+          <pc:docMk/>
+          <pc:sldMk cId="4176680289" sldId="332"/>
+        </pc:sldMkLst>
+        <pc:spChg chg="del mod">
+          <ac:chgData name="Kshitij Tandon" userId="15634347-acbf-4539-84f7-139d21f51226" providerId="ADAL" clId="{0A25E2B8-B0B5-54DF-BADD-6F926CE8A598}" dt="2026-07-06T02:49:37.636" v="204" actId="478"/>
+          <ac:spMkLst>
             <pc:docMk/>
-            <pc:sldMk cId="3138601588" sldId="326"/>
-            <ac:picMk id="3" creationId="{EEFF1C87-3BA3-A053-2960-B78498873602}"/>
-          </ac:picMkLst>
-        </pc:picChg>
-        <pc:picChg chg="add del mod">
-          <ac:chgData name="Kshitij Tandon" userId="15634347-acbf-4539-84f7-139d21f51226" providerId="ADAL" clId="{0A25E2B8-B0B5-54DF-BADD-6F926CE8A598}" dt="2026-06-30T09:13:40.216" v="40" actId="478"/>
-          <ac:picMkLst>
+            <pc:sldMk cId="4176680289" sldId="332"/>
+            <ac:spMk id="2" creationId="{35A9F5B1-6E6E-24C1-5A45-6F2973F5AAED}"/>
+          </ac:spMkLst>
+        </pc:spChg>
+        <pc:spChg chg="del">
+          <ac:chgData name="Kshitij Tandon" userId="15634347-acbf-4539-84f7-139d21f51226" providerId="ADAL" clId="{0A25E2B8-B0B5-54DF-BADD-6F926CE8A598}" dt="2026-07-06T02:49:39.893" v="205" actId="478"/>
+          <ac:spMkLst>
             <pc:docMk/>
-            <pc:sldMk cId="3138601588" sldId="326"/>
-            <ac:picMk id="4" creationId="{FF9852B0-6E2C-6492-0A19-B1D4523F6811}"/>
-          </ac:picMkLst>
-        </pc:picChg>
-        <pc:picChg chg="add del mod modCrop">
-          <ac:chgData name="Kshitij Tandon" userId="15634347-acbf-4539-84f7-139d21f51226" providerId="ADAL" clId="{0A25E2B8-B0B5-54DF-BADD-6F926CE8A598}" dt="2026-07-01T02:06:16.582" v="58" actId="478"/>
-          <ac:picMkLst>
+            <pc:sldMk cId="4176680289" sldId="332"/>
+            <ac:spMk id="3" creationId="{D4DB4155-ABEF-E329-DA2A-8CFA627C8A4D}"/>
+          </ac:spMkLst>
+        </pc:spChg>
+        <pc:spChg chg="mod">
+          <ac:chgData name="Kshitij Tandon" userId="15634347-acbf-4539-84f7-139d21f51226" providerId="ADAL" clId="{0A25E2B8-B0B5-54DF-BADD-6F926CE8A598}" dt="2026-07-06T02:49:26.675" v="202" actId="113"/>
+          <ac:spMkLst>
             <pc:docMk/>
-            <pc:sldMk cId="3138601588" sldId="326"/>
-            <ac:picMk id="7" creationId="{CAC1BA14-B4D3-8EB8-4AEC-775F596F8935}"/>
-          </ac:picMkLst>
-        </pc:picChg>
-        <pc:picChg chg="add del mod modCrop">
-          <ac:chgData name="Kshitij Tandon" userId="15634347-acbf-4539-84f7-139d21f51226" providerId="ADAL" clId="{0A25E2B8-B0B5-54DF-BADD-6F926CE8A598}" dt="2026-07-01T02:06:15.722" v="57" actId="478"/>
-          <ac:picMkLst>
-            <pc:docMk/>
-            <pc:sldMk cId="3138601588" sldId="326"/>
-            <ac:picMk id="8" creationId="{B4B301AF-3FBB-A3E4-15EF-3B8F58BA9DF5}"/>
-          </ac:picMkLst>
-        </pc:picChg>
-        <pc:picChg chg="add del mod modCrop">
-          <ac:chgData name="Kshitij Tandon" userId="15634347-acbf-4539-84f7-139d21f51226" providerId="ADAL" clId="{0A25E2B8-B0B5-54DF-BADD-6F926CE8A598}" dt="2026-07-01T02:06:17.840" v="59" actId="478"/>
-          <ac:picMkLst>
-            <pc:docMk/>
-            <pc:sldMk cId="3138601588" sldId="326"/>
-            <ac:picMk id="9" creationId="{2A59DB71-596A-3D5E-F4AE-CF7FD28B7A14}"/>
-          </ac:picMkLst>
-        </pc:picChg>
+            <pc:sldMk cId="4176680289" sldId="332"/>
+            <ac:spMk id="4" creationId="{8A3F70E5-32DD-99A8-ABB2-49E104792566}"/>
+          </ac:spMkLst>
+        </pc:spChg>
       </pc:sldChg>
     </pc:docChg>
   </pc:docChgLst>
@@ -322,7 +321,7 @@
           <a:p>
             <a:fld id="{02776128-E95C-D045-AE9A-BAEE154ED097}" type="datetimeFigureOut">
               <a:rPr lang="en-US" smtClean="0"/>
-              <a:t>6/30/26</a:t>
+              <a:t>7/6/26</a:t>
             </a:fld>
             <a:endParaRPr lang="en-US"/>
           </a:p>
@@ -872,7 +871,7 @@
             <a:fld id="{00C067AA-C6E9-418C-A333-FC9B7AAB0648}" type="slidenum">
               <a:rPr lang="en-AU" smtClean="0"/>
               <a:pPr/>
-              <a:t>10</a:t>
+              <a:t>11</a:t>
             </a:fld>
             <a:endParaRPr lang="en-AU"/>
           </a:p>
@@ -1089,7 +1088,7 @@
             <a:fld id="{00C067AA-C6E9-418C-A333-FC9B7AAB0648}" type="slidenum">
               <a:rPr lang="en-AU" smtClean="0"/>
               <a:pPr/>
-              <a:t>11</a:t>
+              <a:t>12</a:t>
             </a:fld>
             <a:endParaRPr lang="en-AU"/>
           </a:p>
@@ -1423,7 +1422,7 @@
             <a:fld id="{00C067AA-C6E9-418C-A333-FC9B7AAB0648}" type="slidenum">
               <a:rPr lang="en-AU" smtClean="0"/>
               <a:pPr/>
-              <a:t>3</a:t>
+              <a:t>4</a:t>
             </a:fld>
             <a:endParaRPr lang="en-AU"/>
           </a:p>
@@ -1640,7 +1639,7 @@
             <a:fld id="{00C067AA-C6E9-418C-A333-FC9B7AAB0648}" type="slidenum">
               <a:rPr lang="en-AU" smtClean="0"/>
               <a:pPr/>
-              <a:t>4</a:t>
+              <a:t>5</a:t>
             </a:fld>
             <a:endParaRPr lang="en-AU"/>
           </a:p>
@@ -1857,7 +1856,7 @@
             <a:fld id="{00C067AA-C6E9-418C-A333-FC9B7AAB0648}" type="slidenum">
               <a:rPr lang="en-AU" smtClean="0"/>
               <a:pPr/>
-              <a:t>5</a:t>
+              <a:t>6</a:t>
             </a:fld>
             <a:endParaRPr lang="en-AU"/>
           </a:p>
@@ -2074,7 +2073,7 @@
             <a:fld id="{00C067AA-C6E9-418C-A333-FC9B7AAB0648}" type="slidenum">
               <a:rPr lang="en-AU" smtClean="0"/>
               <a:pPr/>
-              <a:t>6</a:t>
+              <a:t>7</a:t>
             </a:fld>
             <a:endParaRPr lang="en-AU"/>
           </a:p>
@@ -2291,7 +2290,7 @@
             <a:fld id="{00C067AA-C6E9-418C-A333-FC9B7AAB0648}" type="slidenum">
               <a:rPr lang="en-AU" smtClean="0"/>
               <a:pPr/>
-              <a:t>7</a:t>
+              <a:t>8</a:t>
             </a:fld>
             <a:endParaRPr lang="en-AU"/>
           </a:p>
@@ -2508,7 +2507,7 @@
             <a:fld id="{00C067AA-C6E9-418C-A333-FC9B7AAB0648}" type="slidenum">
               <a:rPr lang="en-AU" smtClean="0"/>
               <a:pPr/>
-              <a:t>8</a:t>
+              <a:t>9</a:t>
             </a:fld>
             <a:endParaRPr lang="en-AU"/>
           </a:p>
@@ -2725,7 +2724,7 @@
             <a:fld id="{00C067AA-C6E9-418C-A333-FC9B7AAB0648}" type="slidenum">
               <a:rPr lang="en-AU" smtClean="0"/>
               <a:pPr/>
-              <a:t>9</a:t>
+              <a:t>10</a:t>
             </a:fld>
             <a:endParaRPr lang="en-AU"/>
           </a:p>
@@ -2891,7 +2890,7 @@
           <a:p>
             <a:fld id="{9264E89A-AB25-BB49-ACF5-DB57CC9089B0}" type="datetimeFigureOut">
               <a:rPr lang="en-US" smtClean="0"/>
-              <a:t>6/30/26</a:t>
+              <a:t>7/6/26</a:t>
             </a:fld>
             <a:endParaRPr lang="en-US"/>
           </a:p>
@@ -3089,7 +3088,7 @@
           <a:p>
             <a:fld id="{9264E89A-AB25-BB49-ACF5-DB57CC9089B0}" type="datetimeFigureOut">
               <a:rPr lang="en-US" smtClean="0"/>
-              <a:t>6/30/26</a:t>
+              <a:t>7/6/26</a:t>
             </a:fld>
             <a:endParaRPr lang="en-US"/>
           </a:p>
@@ -3297,7 +3296,7 @@
           <a:p>
             <a:fld id="{9264E89A-AB25-BB49-ACF5-DB57CC9089B0}" type="datetimeFigureOut">
               <a:rPr lang="en-US" smtClean="0"/>
-              <a:t>6/30/26</a:t>
+              <a:t>7/6/26</a:t>
             </a:fld>
             <a:endParaRPr lang="en-US"/>
           </a:p>
@@ -3925,7 +3924,7 @@
           <a:p>
             <a:fld id="{9264E89A-AB25-BB49-ACF5-DB57CC9089B0}" type="datetimeFigureOut">
               <a:rPr lang="en-US" smtClean="0"/>
-              <a:t>6/30/26</a:t>
+              <a:t>7/6/26</a:t>
             </a:fld>
             <a:endParaRPr lang="en-US"/>
           </a:p>
@@ -4200,7 +4199,7 @@
           <a:p>
             <a:fld id="{9264E89A-AB25-BB49-ACF5-DB57CC9089B0}" type="datetimeFigureOut">
               <a:rPr lang="en-US" smtClean="0"/>
-              <a:t>6/30/26</a:t>
+              <a:t>7/6/26</a:t>
             </a:fld>
             <a:endParaRPr lang="en-US"/>
           </a:p>
@@ -4465,7 +4464,7 @@
           <a:p>
             <a:fld id="{9264E89A-AB25-BB49-ACF5-DB57CC9089B0}" type="datetimeFigureOut">
               <a:rPr lang="en-US" smtClean="0"/>
-              <a:t>6/30/26</a:t>
+              <a:t>7/6/26</a:t>
             </a:fld>
             <a:endParaRPr lang="en-US"/>
           </a:p>
@@ -4877,7 +4876,7 @@
           <a:p>
             <a:fld id="{9264E89A-AB25-BB49-ACF5-DB57CC9089B0}" type="datetimeFigureOut">
               <a:rPr lang="en-US" smtClean="0"/>
-              <a:t>6/30/26</a:t>
+              <a:t>7/6/26</a:t>
             </a:fld>
             <a:endParaRPr lang="en-US"/>
           </a:p>
@@ -5018,7 +5017,7 @@
           <a:p>
             <a:fld id="{9264E89A-AB25-BB49-ACF5-DB57CC9089B0}" type="datetimeFigureOut">
               <a:rPr lang="en-US" smtClean="0"/>
-              <a:t>6/30/26</a:t>
+              <a:t>7/6/26</a:t>
             </a:fld>
             <a:endParaRPr lang="en-US"/>
           </a:p>
@@ -5131,7 +5130,7 @@
           <a:p>
             <a:fld id="{9264E89A-AB25-BB49-ACF5-DB57CC9089B0}" type="datetimeFigureOut">
               <a:rPr lang="en-US" smtClean="0"/>
-              <a:t>6/30/26</a:t>
+              <a:t>7/6/26</a:t>
             </a:fld>
             <a:endParaRPr lang="en-US"/>
           </a:p>
@@ -5442,7 +5441,7 @@
           <a:p>
             <a:fld id="{9264E89A-AB25-BB49-ACF5-DB57CC9089B0}" type="datetimeFigureOut">
               <a:rPr lang="en-US" smtClean="0"/>
-              <a:t>6/30/26</a:t>
+              <a:t>7/6/26</a:t>
             </a:fld>
             <a:endParaRPr lang="en-US"/>
           </a:p>
@@ -5730,7 +5729,7 @@
           <a:p>
             <a:fld id="{9264E89A-AB25-BB49-ACF5-DB57CC9089B0}" type="datetimeFigureOut">
               <a:rPr lang="en-US" smtClean="0"/>
-              <a:t>6/30/26</a:t>
+              <a:t>7/6/26</a:t>
             </a:fld>
             <a:endParaRPr lang="en-US"/>
           </a:p>
@@ -5971,7 +5970,7 @@
           <a:p>
             <a:fld id="{9264E89A-AB25-BB49-ACF5-DB57CC9089B0}" type="datetimeFigureOut">
               <a:rPr lang="en-US" smtClean="0"/>
-              <a:t>6/30/26</a:t>
+              <a:t>7/6/26</a:t>
             </a:fld>
             <a:endParaRPr lang="en-US"/>
           </a:p>
@@ -7208,6 +7207,111 @@
           <p:cNvPr id="5" name="Text Placeholder 4">
             <a:extLst>
               <a:ext uri="{FF2B5EF4-FFF2-40B4-BE49-F238E27FC236}">
+                <a16:creationId xmlns:a16="http://schemas.microsoft.com/office/drawing/2014/main" id="{6643CEE1-8E7C-7DBF-54B9-74206F746A79}"/>
+              </a:ext>
+            </a:extLst>
+          </p:cNvPr>
+          <p:cNvSpPr>
+            <a:spLocks noGrp="1"/>
+          </p:cNvSpPr>
+          <p:nvPr>
+            <p:ph type="body" sz="quarter" idx="13"/>
+          </p:nvPr>
+        </p:nvSpPr>
+        <p:spPr/>
+        <p:txBody>
+          <a:bodyPr/>
+          <a:lstStyle/>
+          <a:p>
+            <a:endParaRPr lang="en-US"/>
+          </a:p>
+        </p:txBody>
+      </p:sp>
+      <p:sp>
+        <p:nvSpPr>
+          <p:cNvPr id="6" name="TextBox 5">
+            <a:extLst>
+              <a:ext uri="{FF2B5EF4-FFF2-40B4-BE49-F238E27FC236}">
+                <a16:creationId xmlns:a16="http://schemas.microsoft.com/office/drawing/2014/main" id="{D087C49A-813F-2E94-D88F-C3BE92E9C56F}"/>
+              </a:ext>
+            </a:extLst>
+          </p:cNvPr>
+          <p:cNvSpPr txBox="1"/>
+          <p:nvPr/>
+        </p:nvSpPr>
+        <p:spPr>
+          <a:xfrm>
+            <a:off x="11022448" y="91883"/>
+            <a:ext cx="1169552" cy="198516"/>
+          </a:xfrm>
+          <a:prstGeom prst="rect">
+            <a:avLst/>
+          </a:prstGeom>
+          <a:noFill/>
+        </p:spPr>
+        <p:txBody>
+          <a:bodyPr wrap="none" lIns="45720" tIns="18288" rIns="45720" bIns="18288" anchor="ctr">
+            <a:spAutoFit/>
+          </a:bodyPr>
+          <a:lstStyle/>
+          <a:p>
+            <a:pPr algn="r"/>
+            <a:r>
+              <a:rPr sz="1050" b="0" dirty="0">
+                <a:solidFill>
+                  <a:srgbClr val="969696"/>
+                </a:solidFill>
+                <a:latin typeface="Aptos"/>
+              </a:rPr>
+              <a:t>FISABIO workshop</a:t>
+            </a:r>
+          </a:p>
+        </p:txBody>
+      </p:sp>
+    </p:spTree>
+    <p:extLst>
+      <p:ext uri="{BB962C8B-B14F-4D97-AF65-F5344CB8AC3E}">
+        <p14:creationId xmlns:p14="http://schemas.microsoft.com/office/powerpoint/2010/main" val="2917721761"/>
+      </p:ext>
+    </p:extLst>
+  </p:cSld>
+  <p:clrMapOvr>
+    <a:masterClrMapping/>
+  </p:clrMapOvr>
+  <p:transition>
+    <p:fade/>
+  </p:transition>
+</p:sld>
+</file>
+
+<file path=ppt/slides/slide11.xml><?xml version="1.0" encoding="utf-8"?>
+<p:sld xmlns:a="http://schemas.openxmlformats.org/drawingml/2006/main" xmlns:r="http://schemas.openxmlformats.org/officeDocument/2006/relationships" xmlns:p="http://schemas.openxmlformats.org/presentationml/2006/main">
+  <p:cSld>
+    <p:spTree>
+      <p:nvGrpSpPr>
+        <p:cNvPr id="1" name="">
+          <a:extLst>
+            <a:ext uri="{FF2B5EF4-FFF2-40B4-BE49-F238E27FC236}">
+              <a16:creationId xmlns:a16="http://schemas.microsoft.com/office/drawing/2014/main" id="{D20C7CDB-BB21-5551-AD41-068B73F8EE76}"/>
+            </a:ext>
+          </a:extLst>
+        </p:cNvPr>
+        <p:cNvGrpSpPr/>
+        <p:nvPr/>
+      </p:nvGrpSpPr>
+      <p:grpSpPr>
+        <a:xfrm>
+          <a:off x="0" y="0"/>
+          <a:ext cx="0" cy="0"/>
+          <a:chOff x="0" y="0"/>
+          <a:chExt cx="0" cy="0"/>
+        </a:xfrm>
+      </p:grpSpPr>
+      <p:sp>
+        <p:nvSpPr>
+          <p:cNvPr id="5" name="Text Placeholder 4">
+            <a:extLst>
+              <a:ext uri="{FF2B5EF4-FFF2-40B4-BE49-F238E27FC236}">
                 <a16:creationId xmlns:a16="http://schemas.microsoft.com/office/drawing/2014/main" id="{4BF34DDC-4A4B-65D6-BF7F-46E783FC681C}"/>
               </a:ext>
             </a:extLst>
@@ -7285,7 +7389,7 @@
 </p:sld>
 </file>
 
-<file path=ppt/slides/slide11.xml><?xml version="1.0" encoding="utf-8"?>
+<file path=ppt/slides/slide12.xml><?xml version="1.0" encoding="utf-8"?>
 <p:sld xmlns:a="http://schemas.openxmlformats.org/drawingml/2006/main" xmlns:r="http://schemas.openxmlformats.org/officeDocument/2006/relationships" xmlns:p="http://schemas.openxmlformats.org/presentationml/2006/main">
   <p:cSld>
     <p:spTree>
@@ -7445,7 +7549,7 @@
               <a:buNone/>
             </a:pPr>
             <a:r>
-              <a:rPr lang="en-US" dirty="0"/>
+              <a:rPr lang="en-US" b="1" dirty="0"/>
               <a:t>Bacteria are second largest contributors to Earth’s Biomass </a:t>
             </a:r>
           </a:p>
@@ -7811,6 +7915,82 @@
 </file>
 
 <file path=ppt/slides/slide3.xml><?xml version="1.0" encoding="utf-8"?>
+<p:sld xmlns:a="http://schemas.openxmlformats.org/drawingml/2006/main" xmlns:r="http://schemas.openxmlformats.org/officeDocument/2006/relationships" xmlns:p="http://schemas.openxmlformats.org/presentationml/2006/main">
+  <p:cSld>
+    <p:spTree>
+      <p:nvGrpSpPr>
+        <p:cNvPr id="1" name=""/>
+        <p:cNvGrpSpPr/>
+        <p:nvPr/>
+      </p:nvGrpSpPr>
+      <p:grpSpPr>
+        <a:xfrm>
+          <a:off x="0" y="0"/>
+          <a:ext cx="0" cy="0"/>
+          <a:chOff x="0" y="0"/>
+          <a:chExt cx="0" cy="0"/>
+        </a:xfrm>
+      </p:grpSpPr>
+      <p:sp>
+        <p:nvSpPr>
+          <p:cNvPr id="4" name="Text Placeholder 3">
+            <a:extLst>
+              <a:ext uri="{FF2B5EF4-FFF2-40B4-BE49-F238E27FC236}">
+                <a16:creationId xmlns:a16="http://schemas.microsoft.com/office/drawing/2014/main" id="{8A3F70E5-32DD-99A8-ABB2-49E104792566}"/>
+              </a:ext>
+            </a:extLst>
+          </p:cNvPr>
+          <p:cNvSpPr>
+            <a:spLocks noGrp="1"/>
+          </p:cNvSpPr>
+          <p:nvPr>
+            <p:ph type="body" sz="quarter" idx="13"/>
+          </p:nvPr>
+        </p:nvSpPr>
+        <p:spPr>
+          <a:xfrm>
+            <a:off x="371475" y="396875"/>
+            <a:ext cx="10557782" cy="868363"/>
+          </a:xfrm>
+        </p:spPr>
+        <p:txBody>
+          <a:bodyPr>
+            <a:normAutofit/>
+          </a:bodyPr>
+          <a:lstStyle/>
+          <a:p>
+            <a:pPr marL="0" indent="0">
+              <a:buNone/>
+            </a:pPr>
+            <a:r>
+              <a:rPr lang="en-US" b="1" dirty="0"/>
+              <a:t>In vitro culturing remains a significant </a:t>
+            </a:r>
+            <a:r>
+              <a:rPr lang="en-US" b="1" dirty="0" err="1"/>
+              <a:t>bootleneck</a:t>
+            </a:r>
+            <a:endParaRPr lang="en-US" b="1" dirty="0"/>
+          </a:p>
+        </p:txBody>
+      </p:sp>
+    </p:spTree>
+    <p:extLst>
+      <p:ext uri="{BB962C8B-B14F-4D97-AF65-F5344CB8AC3E}">
+        <p14:creationId xmlns:p14="http://schemas.microsoft.com/office/powerpoint/2010/main" val="4176680289"/>
+      </p:ext>
+    </p:extLst>
+  </p:cSld>
+  <p:clrMapOvr>
+    <a:masterClrMapping/>
+  </p:clrMapOvr>
+  <p:transition>
+    <p:fade/>
+  </p:transition>
+</p:sld>
+</file>
+
+<file path=ppt/slides/slide4.xml><?xml version="1.0" encoding="utf-8"?>
 <p:sld xmlns:a="http://schemas.openxmlformats.org/drawingml/2006/main" xmlns:r="http://schemas.openxmlformats.org/officeDocument/2006/relationships" xmlns:p="http://schemas.openxmlformats.org/presentationml/2006/main">
   <p:cSld>
     <p:spTree>
@@ -8980,7 +9160,7 @@
 </p:sld>
 </file>
 
-<file path=ppt/slides/slide4.xml><?xml version="1.0" encoding="utf-8"?>
+<file path=ppt/slides/slide5.xml><?xml version="1.0" encoding="utf-8"?>
 <p:sld xmlns:a="http://schemas.openxmlformats.org/drawingml/2006/main" xmlns:r="http://schemas.openxmlformats.org/officeDocument/2006/relationships" xmlns:p="http://schemas.openxmlformats.org/presentationml/2006/main">
   <p:cSld>
     <p:spTree>
@@ -10400,7 +10580,7 @@
 </p:sld>
 </file>
 
-<file path=ppt/slides/slide5.xml><?xml version="1.0" encoding="utf-8"?>
+<file path=ppt/slides/slide6.xml><?xml version="1.0" encoding="utf-8"?>
 <p:sld xmlns:a="http://schemas.openxmlformats.org/drawingml/2006/main" xmlns:r="http://schemas.openxmlformats.org/officeDocument/2006/relationships" xmlns:p="http://schemas.openxmlformats.org/presentationml/2006/main">
   <p:cSld>
     <p:spTree>
@@ -10561,7 +10741,7 @@
 </p:sld>
 </file>
 
-<file path=ppt/slides/slide6.xml><?xml version="1.0" encoding="utf-8"?>
+<file path=ppt/slides/slide7.xml><?xml version="1.0" encoding="utf-8"?>
 <p:sld xmlns:a="http://schemas.openxmlformats.org/drawingml/2006/main" xmlns:r="http://schemas.openxmlformats.org/officeDocument/2006/relationships" xmlns:p="http://schemas.openxmlformats.org/presentationml/2006/main">
   <p:cSld>
     <p:spTree>
@@ -10699,111 +10879,6 @@
 </p:sld>
 </file>
 
-<file path=ppt/slides/slide7.xml><?xml version="1.0" encoding="utf-8"?>
-<p:sld xmlns:a="http://schemas.openxmlformats.org/drawingml/2006/main" xmlns:r="http://schemas.openxmlformats.org/officeDocument/2006/relationships" xmlns:p="http://schemas.openxmlformats.org/presentationml/2006/main">
-  <p:cSld>
-    <p:spTree>
-      <p:nvGrpSpPr>
-        <p:cNvPr id="1" name="">
-          <a:extLst>
-            <a:ext uri="{FF2B5EF4-FFF2-40B4-BE49-F238E27FC236}">
-              <a16:creationId xmlns:a16="http://schemas.microsoft.com/office/drawing/2014/main" id="{D20C7CDB-BB21-5551-AD41-068B73F8EE76}"/>
-            </a:ext>
-          </a:extLst>
-        </p:cNvPr>
-        <p:cNvGrpSpPr/>
-        <p:nvPr/>
-      </p:nvGrpSpPr>
-      <p:grpSpPr>
-        <a:xfrm>
-          <a:off x="0" y="0"/>
-          <a:ext cx="0" cy="0"/>
-          <a:chOff x="0" y="0"/>
-          <a:chExt cx="0" cy="0"/>
-        </a:xfrm>
-      </p:grpSpPr>
-      <p:sp>
-        <p:nvSpPr>
-          <p:cNvPr id="5" name="Text Placeholder 4">
-            <a:extLst>
-              <a:ext uri="{FF2B5EF4-FFF2-40B4-BE49-F238E27FC236}">
-                <a16:creationId xmlns:a16="http://schemas.microsoft.com/office/drawing/2014/main" id="{D28AE6AC-5B14-4696-8187-78135F0B058E}"/>
-              </a:ext>
-            </a:extLst>
-          </p:cNvPr>
-          <p:cNvSpPr>
-            <a:spLocks noGrp="1"/>
-          </p:cNvSpPr>
-          <p:nvPr>
-            <p:ph type="body" sz="quarter" idx="13"/>
-          </p:nvPr>
-        </p:nvSpPr>
-        <p:spPr/>
-        <p:txBody>
-          <a:bodyPr/>
-          <a:lstStyle/>
-          <a:p>
-            <a:endParaRPr lang="en-US" dirty="0"/>
-          </a:p>
-        </p:txBody>
-      </p:sp>
-      <p:sp>
-        <p:nvSpPr>
-          <p:cNvPr id="6" name="TextBox 5">
-            <a:extLst>
-              <a:ext uri="{FF2B5EF4-FFF2-40B4-BE49-F238E27FC236}">
-                <a16:creationId xmlns:a16="http://schemas.microsoft.com/office/drawing/2014/main" id="{C15451FA-997D-15A7-8E6A-D1CB64664B0B}"/>
-              </a:ext>
-            </a:extLst>
-          </p:cNvPr>
-          <p:cNvSpPr txBox="1"/>
-          <p:nvPr/>
-        </p:nvSpPr>
-        <p:spPr>
-          <a:xfrm>
-            <a:off x="11022448" y="91883"/>
-            <a:ext cx="1169552" cy="198516"/>
-          </a:xfrm>
-          <a:prstGeom prst="rect">
-            <a:avLst/>
-          </a:prstGeom>
-          <a:noFill/>
-        </p:spPr>
-        <p:txBody>
-          <a:bodyPr wrap="none" lIns="45720" tIns="18288" rIns="45720" bIns="18288" anchor="ctr">
-            <a:spAutoFit/>
-          </a:bodyPr>
-          <a:lstStyle/>
-          <a:p>
-            <a:pPr algn="r"/>
-            <a:r>
-              <a:rPr sz="1050" b="0" dirty="0">
-                <a:solidFill>
-                  <a:srgbClr val="969696"/>
-                </a:solidFill>
-                <a:latin typeface="Aptos"/>
-              </a:rPr>
-              <a:t>FISABIO workshop</a:t>
-            </a:r>
-          </a:p>
-        </p:txBody>
-      </p:sp>
-    </p:spTree>
-    <p:extLst>
-      <p:ext uri="{BB962C8B-B14F-4D97-AF65-F5344CB8AC3E}">
-        <p14:creationId xmlns:p14="http://schemas.microsoft.com/office/powerpoint/2010/main" val="3138601588"/>
-      </p:ext>
-    </p:extLst>
-  </p:cSld>
-  <p:clrMapOvr>
-    <a:masterClrMapping/>
-  </p:clrMapOvr>
-  <p:transition>
-    <p:fade/>
-  </p:transition>
-</p:sld>
-</file>
-
 <file path=ppt/slides/slide8.xml><?xml version="1.0" encoding="utf-8"?>
 <p:sld xmlns:a="http://schemas.openxmlformats.org/drawingml/2006/main" xmlns:r="http://schemas.openxmlformats.org/officeDocument/2006/relationships" xmlns:p="http://schemas.openxmlformats.org/presentationml/2006/main">
   <p:cSld>
@@ -10832,7 +10907,7 @@
           <p:cNvPr id="5" name="Text Placeholder 4">
             <a:extLst>
               <a:ext uri="{FF2B5EF4-FFF2-40B4-BE49-F238E27FC236}">
-                <a16:creationId xmlns:a16="http://schemas.microsoft.com/office/drawing/2014/main" id="{1E26B140-E014-EDD3-C7C9-46803E8C6DF6}"/>
+                <a16:creationId xmlns:a16="http://schemas.microsoft.com/office/drawing/2014/main" id="{D28AE6AC-5B14-4696-8187-78135F0B058E}"/>
               </a:ext>
             </a:extLst>
           </p:cNvPr>
@@ -10848,7 +10923,7 @@
           <a:bodyPr/>
           <a:lstStyle/>
           <a:p>
-            <a:endParaRPr lang="en-US"/>
+            <a:endParaRPr lang="en-US" dirty="0"/>
           </a:p>
         </p:txBody>
       </p:sp>
@@ -10857,7 +10932,7 @@
           <p:cNvPr id="6" name="TextBox 5">
             <a:extLst>
               <a:ext uri="{FF2B5EF4-FFF2-40B4-BE49-F238E27FC236}">
-                <a16:creationId xmlns:a16="http://schemas.microsoft.com/office/drawing/2014/main" id="{23940A24-4C42-2208-C8FB-0FB696447C07}"/>
+                <a16:creationId xmlns:a16="http://schemas.microsoft.com/office/drawing/2014/main" id="{C15451FA-997D-15A7-8E6A-D1CB64664B0B}"/>
               </a:ext>
             </a:extLst>
           </p:cNvPr>
@@ -10896,7 +10971,7 @@
     </p:spTree>
     <p:extLst>
       <p:ext uri="{BB962C8B-B14F-4D97-AF65-F5344CB8AC3E}">
-        <p14:creationId xmlns:p14="http://schemas.microsoft.com/office/powerpoint/2010/main" val="1978806818"/>
+        <p14:creationId xmlns:p14="http://schemas.microsoft.com/office/powerpoint/2010/main" val="3138601588"/>
       </p:ext>
     </p:extLst>
   </p:cSld>
@@ -10937,7 +11012,7 @@
           <p:cNvPr id="5" name="Text Placeholder 4">
             <a:extLst>
               <a:ext uri="{FF2B5EF4-FFF2-40B4-BE49-F238E27FC236}">
-                <a16:creationId xmlns:a16="http://schemas.microsoft.com/office/drawing/2014/main" id="{6643CEE1-8E7C-7DBF-54B9-74206F746A79}"/>
+                <a16:creationId xmlns:a16="http://schemas.microsoft.com/office/drawing/2014/main" id="{1E26B140-E014-EDD3-C7C9-46803E8C6DF6}"/>
               </a:ext>
             </a:extLst>
           </p:cNvPr>
@@ -10962,7 +11037,7 @@
           <p:cNvPr id="6" name="TextBox 5">
             <a:extLst>
               <a:ext uri="{FF2B5EF4-FFF2-40B4-BE49-F238E27FC236}">
-                <a16:creationId xmlns:a16="http://schemas.microsoft.com/office/drawing/2014/main" id="{D087C49A-813F-2E94-D88F-C3BE92E9C56F}"/>
+                <a16:creationId xmlns:a16="http://schemas.microsoft.com/office/drawing/2014/main" id="{23940A24-4C42-2208-C8FB-0FB696447C07}"/>
               </a:ext>
             </a:extLst>
           </p:cNvPr>
@@ -11001,7 +11076,7 @@
     </p:spTree>
     <p:extLst>
       <p:ext uri="{BB962C8B-B14F-4D97-AF65-F5344CB8AC3E}">
-        <p14:creationId xmlns:p14="http://schemas.microsoft.com/office/powerpoint/2010/main" val="2917721761"/>
+        <p14:creationId xmlns:p14="http://schemas.microsoft.com/office/powerpoint/2010/main" val="1978806818"/>
       </p:ext>
     </p:extLst>
   </p:cSld>

</xml_diff>